<commit_message>
docs: refresh deck and notes for the on-chain results
</commit_message>
<xml_diff>
--- a/docs/pay-parity-deck.pptx
+++ b/docs/pay-parity-deck.pptx
@@ -3240,7 +3240,7 @@
       </p:sp>
       <p:pic>
         <p:nvPicPr>
-          <p:cNvPr id="3" name="Screenshot" descr="C:/dev/pay-parity/docs/demo.jpg">    </p:cNvPr>
+          <p:cNvPr id="3" name="Screenshot" descr="C:/dev/pay-parity/docs/demo-chain.jpg">    </p:cNvPr>
           <p:cNvPicPr>
             <a:picLocks noChangeAspect="1"/>
           </p:cNvPicPr>
@@ -3485,7 +3485,7 @@
                 <a:ea typeface="Cambria" pitchFamily="34" charset="-122"/>
                 <a:cs typeface="Cambria" pitchFamily="34" charset="-120"/>
               </a:rPr>
-              <a:t>Tested against the compiled contract</a:t>
+              <a:t>Tested in-process and on a real network</a:t>
             </a:r>
             <a:endParaRPr lang="en-US" sz="3600" dirty="0"/>
           </a:p>
@@ -3551,7 +3551,7 @@
                 <a:ea typeface="Cambria" pitchFamily="34" charset="-122"/>
                 <a:cs typeface="Cambria" pitchFamily="34" charset="-120"/>
               </a:rPr>
-              <a:t>31</a:t>
+              <a:t>31 + 8</a:t>
             </a:r>
             <a:endParaRPr lang="en-US" sz="6000" dirty="0"/>
           </a:p>
@@ -3590,7 +3590,7 @@
                 <a:ea typeface="Calibri" pitchFamily="34" charset="-122"/>
                 <a:cs typeface="Calibri" pitchFamily="34" charset="-120"/>
               </a:rPr>
-              <a:t>tests, all passing</a:t>
+              <a:t>unit tests plus on-chain tests, all passing</a:t>
             </a:r>
             <a:endParaRPr lang="en-US" sz="1500" dirty="0"/>
           </a:p>
@@ -3695,7 +3695,7 @@
                 <a:ea typeface="Calibri" pitchFamily="34" charset="-122"/>
                 <a:cs typeface="Calibri" pitchFamily="34" charset="-120"/>
               </a:rPr>
-              <a:t>salaries in public state, checked as decimals and ledger bytes</a:t>
+              <a:t>salaries in public state, checked in-process and read back from the chain</a:t>
             </a:r>
             <a:endParaRPr lang="en-US" sz="1500" dirty="0"/>
           </a:p>
@@ -3885,7 +3885,7 @@
                 <a:ea typeface="Calibri" pitchFamily="34" charset="-122"/>
                 <a:cs typeface="Calibri" pitchFamily="34" charset="-120"/>
               </a:rPr>
-              <a:t>Tests were run against deliberate mutations of the contract and caught them. CI compiles, typechecks and tests on every push.</a:t>
+              <a:t>The on-chain suite deploys to a local Midnight network and submits audits with real zero-knowledge proofs. CI compiles, typechecks and tests on every push.</a:t>
             </a:r>
             <a:endParaRPr lang="en-US" sz="1600" dirty="0"/>
           </a:p>
@@ -4396,7 +4396,7 @@
                 <a:ea typeface="Calibri" pitchFamily="34" charset="-122"/>
                 <a:cs typeface="Calibri" pitchFamily="34" charset="-120"/>
               </a:rPr>
-              <a:t>Demo runs the contract in-process: no network, no ZK proof yet</a:t>
+              <a:t>Tested on a local Midnight network, not yet on Preprod</a:t>
             </a:r>
             <a:endParaRPr lang="en-US" sz="1600" dirty="0"/>
           </a:p>
@@ -4520,7 +4520,7 @@
                 <a:ea typeface="Calibri" pitchFamily="34" charset="-122"/>
                 <a:cs typeface="Calibri" pitchFamily="34" charset="-120"/>
               </a:rPr>
-              <a:t>Deploy to Preprod and run audits with real proofs</a:t>
+              <a:t>Deploy to Preprod with a funded wallet</a:t>
             </a:r>
             <a:endParaRPr lang="en-US" sz="1600" dirty="0"/>
           </a:p>

</xml_diff>

<commit_message>
docs: deck update for the Preprod deployment
</commit_message>
<xml_diff>
--- a/docs/pay-parity-deck.pptx
+++ b/docs/pay-parity-deck.pptx
@@ -3485,7 +3485,7 @@
                 <a:ea typeface="Cambria" pitchFamily="34" charset="-122"/>
                 <a:cs typeface="Cambria" pitchFamily="34" charset="-120"/>
               </a:rPr>
-              <a:t>Tested in-process and on a real network</a:t>
+              <a:t>Tested locally, on-chain and live on Preprod</a:t>
             </a:r>
             <a:endParaRPr lang="en-US" sz="3600" dirty="0"/>
           </a:p>
@@ -3885,9 +3885,48 @@
                 <a:ea typeface="Calibri" pitchFamily="34" charset="-122"/>
                 <a:cs typeface="Calibri" pitchFamily="34" charset="-120"/>
               </a:rPr>
-              <a:t>The on-chain suite deploys to a local Midnight network and submits audits with real zero-knowledge proofs. CI compiles, typechecks and tests on every push.</a:t>
+              <a:t>Deployed to Midnight Preprod, with two audits recorded by real proven transactions. The on-chain suite does the same on a local network. CI compiles, typechecks and tests on every push.</a:t>
             </a:r>
             <a:endParaRPr lang="en-US" sz="1600" dirty="0"/>
+          </a:p>
+        </p:txBody>
+      </p:sp>
+      <p:sp>
+        <p:nvSpPr>
+          <p:cNvPr id="13" name="Preprod contract"/>
+          <p:cNvSpPr txBox="1"/>
+          <p:nvPr/>
+        </p:nvSpPr>
+        <p:spPr>
+          <a:xfrm>
+            <a:off x="731520" y="6172200"/>
+            <a:ext cx="10725912" cy="320040"/>
+          </a:xfrm>
+          <a:prstGeom prst="rect">
+            <a:avLst/>
+          </a:prstGeom>
+          <a:noFill/>
+          <a:ln/>
+        </p:spPr>
+        <p:txBody>
+          <a:bodyPr wrap="square" lIns="0" tIns="0" rIns="0" bIns="0" rtlCol="0" anchor="ctr"/>
+          <a:lstStyle/>
+          <a:p>
+            <a:pPr indent="0" marL="0">
+              <a:buNone/>
+            </a:pPr>
+            <a:r>
+              <a:rPr lang="en-US" sz="1100" dirty="0">
+                <a:solidFill>
+                  <a:srgbClr val="5E5E58"/>
+                </a:solidFill>
+                <a:latin typeface="Calibri" pitchFamily="34" charset="0"/>
+                <a:ea typeface="Calibri" pitchFamily="34" charset="-122"/>
+                <a:cs typeface="Calibri" pitchFamily="34" charset="-120"/>
+              </a:rPr>
+              <a:t>Preprod contract f4e684d9e05b892e8427cba2296e08a96c0086cd12fe5c618c3c53064add8d05, searchable at preprod.midnightexplorer.com</a:t>
+            </a:r>
+            <a:endParaRPr lang="en-US" sz="1100" dirty="0"/>
           </a:p>
         </p:txBody>
       </p:sp>
@@ -4396,7 +4435,7 @@
                 <a:ea typeface="Calibri" pitchFamily="34" charset="-122"/>
                 <a:cs typeface="Calibri" pitchFamily="34" charset="-120"/>
               </a:rPr>
-              <a:t>Tested on a local Midnight network, not yet on Preprod</a:t>
+              <a:t>Live on Preprod, but the two audits use made-up pay data</a:t>
             </a:r>
             <a:endParaRPr lang="en-US" sz="1600" dirty="0"/>
           </a:p>
@@ -4520,7 +4559,7 @@
                 <a:ea typeface="Calibri" pitchFamily="34" charset="-122"/>
                 <a:cs typeface="Calibri" pitchFamily="34" charset="-120"/>
               </a:rPr>
-              <a:t>Deploy to Preprod with a funded wallet</a:t>
+              <a:t>Pilot with a real employer payroll export</a:t>
             </a:r>
             <a:endParaRPr lang="en-US" sz="1600" dirty="0"/>
           </a:p>

</xml_diff>